<commit_message>
fix: plantilla PPTX EU, texto de la diapositiva Sarrera
</commit_message>
<xml_diff>
--- a/PLANTILLA_PPT/INEDUS2026_plantilla_EU.pptx
+++ b/PLANTILLA_PPT/INEDUS2026_plantilla_EU.pptx
@@ -1575,7 +1575,7 @@
           </a:prstGeom>
           <a:extLst>
             <a:ext uri="{C572A759-6A51-4108-AA02-DFA0A04FC94B}">
-              <ma14:wrappingTextBoxFlag xmlns:ma14="http://schemas.microsoft.com/office/mac/drawingml/2011/main" xmlns="" val="0"/>
+              <ma14:wrappingTextBoxFlag xmlns="" xmlns:ma14="http://schemas.microsoft.com/office/mac/drawingml/2011/main" val="0"/>
             </a:ext>
           </a:extLst>
         </p:spPr>
@@ -1912,7 +1912,7 @@
           </a:prstGeom>
           <a:extLst>
             <a:ext uri="{C572A759-6A51-4108-AA02-DFA0A04FC94B}">
-              <ma14:wrappingTextBoxFlag xmlns:ma14="http://schemas.microsoft.com/office/mac/drawingml/2011/main" xmlns="" val="0"/>
+              <ma14:wrappingTextBoxFlag xmlns="" xmlns:ma14="http://schemas.microsoft.com/office/mac/drawingml/2011/main" val="0"/>
             </a:ext>
           </a:extLst>
         </p:spPr>
@@ -2514,7 +2514,23 @@
                   <a:srgbClr val="1B2433"/>
                 </a:solidFill>
               </a:rPr>
-              <a:t>Ikerketa-arazoa edo -galdera</a:t>
+              <a:t>Ikerketa-arazoa </a:t>
+            </a:r>
+            <a:r>
+              <a:rPr lang="en-US" sz="1800" dirty="0" err="1">
+                <a:solidFill>
+                  <a:srgbClr val="1B2433"/>
+                </a:solidFill>
+              </a:rPr>
+              <a:t>edo</a:t>
+            </a:r>
+            <a:r>
+              <a:rPr lang="en-US" sz="1800">
+                <a:solidFill>
+                  <a:srgbClr val="1B2433"/>
+                </a:solidFill>
+              </a:rPr>
+              <a:t> galdera</a:t>
             </a:r>
             <a:endParaRPr lang="en-US" sz="1800" dirty="0"/>
           </a:p>
@@ -2687,7 +2703,7 @@
           </a:prstGeom>
           <a:extLst>
             <a:ext uri="{C572A759-6A51-4108-AA02-DFA0A04FC94B}">
-              <ma14:wrappingTextBoxFlag xmlns:ma14="http://schemas.microsoft.com/office/mac/drawingml/2011/main" xmlns="" val="0"/>
+              <ma14:wrappingTextBoxFlag xmlns="" xmlns:ma14="http://schemas.microsoft.com/office/mac/drawingml/2011/main" val="0"/>
             </a:ext>
           </a:extLst>
         </p:spPr>
@@ -3035,7 +3051,7 @@
           </a:prstGeom>
           <a:extLst>
             <a:ext uri="{C572A759-6A51-4108-AA02-DFA0A04FC94B}">
-              <ma14:wrappingTextBoxFlag xmlns:ma14="http://schemas.microsoft.com/office/mac/drawingml/2011/main" xmlns="" val="0"/>
+              <ma14:wrappingTextBoxFlag xmlns="" xmlns:ma14="http://schemas.microsoft.com/office/mac/drawingml/2011/main" val="0"/>
             </a:ext>
           </a:extLst>
         </p:spPr>
@@ -3667,7 +3683,7 @@
           </a:prstGeom>
           <a:extLst>
             <a:ext uri="{C572A759-6A51-4108-AA02-DFA0A04FC94B}">
-              <ma14:wrappingTextBoxFlag xmlns:ma14="http://schemas.microsoft.com/office/mac/drawingml/2011/main" xmlns="" val="0"/>
+              <ma14:wrappingTextBoxFlag xmlns="" xmlns:ma14="http://schemas.microsoft.com/office/mac/drawingml/2011/main" val="0"/>
             </a:ext>
           </a:extLst>
         </p:spPr>

</xml_diff>

<commit_message>
fix: restaurar diapositiva Metodologia en la plantilla PPTX EU
</commit_message>
<xml_diff>
--- a/PLANTILLA_PPT/INEDUS2026_plantilla_EU.pptx
+++ b/PLANTILLA_PPT/INEDUS2026_plantilla_EU.pptx
@@ -10,6 +10,7 @@
   <p:sldIdLst>
     <p:sldId id="256" r:id="rId2"/>
     <p:sldId id="258" r:id="rId3"/>
+    <p:sldId id="266" r:id="rId12"/>
     <p:sldId id="262" r:id="rId4"/>
     <p:sldId id="264" r:id="rId5"/>
     <p:sldId id="265" r:id="rId6"/>
@@ -3854,6 +3855,756 @@
               <a:t>www.inedus.net</a:t>
             </a:r>
             <a:endParaRPr lang="en-US" sz="1800" dirty="0"/>
+          </a:p>
+        </p:txBody>
+      </p:sp>
+    </p:spTree>
+  </p:cSld>
+  <p:clrMapOvr>
+    <a:masterClrMapping/>
+  </p:clrMapOvr>
+</p:sld>
+</file>
+
+<file path=ppt/slides/slide6.xml><?xml version="1.0" encoding="utf-8"?>
+<p:sld xmlns:a="http://schemas.openxmlformats.org/drawingml/2006/main" xmlns:r="http://schemas.openxmlformats.org/officeDocument/2006/relationships" xmlns:p="http://schemas.openxmlformats.org/presentationml/2006/main">
+  <p:cSld name="Slide 3">
+    <p:spTree>
+      <p:nvGrpSpPr>
+        <p:cNvPr id="2" name=""/>
+        <p:cNvGrpSpPr/>
+        <p:nvPr/>
+      </p:nvGrpSpPr>
+      <p:grpSpPr>
+        <a:xfrm>
+          <a:off x="0" y="0"/>
+          <a:ext cx="0" cy="0"/>
+          <a:chOff x="0" y="0"/>
+          <a:chExt cx="0" cy="0"/>
+        </a:xfrm>
+      </p:grpSpPr>
+      <p:sp>
+        <p:nvSpPr>
+          <p:cNvPr id="3" name="Text 0"/>
+          <p:cNvSpPr>
+            <a:spLocks noGrp="1"/>
+          </p:cNvSpPr>
+          <p:nvPr>
+            <p:ph type="title" idx="101" hasCustomPrompt="1"/>
+          </p:nvPr>
+        </p:nvSpPr>
+        <p:spPr>
+          <a:xfrm>
+            <a:off x="548640" y="411480"/>
+            <a:ext cx="6400800" cy="731520"/>
+          </a:xfrm>
+          <a:prstGeom prst="rect">
+            <a:avLst/>
+          </a:prstGeom>
+          <a:noFill/>
+          <a:ln/>
+        </p:spPr>
+        <p:txBody>
+          <a:bodyPr wrap="square" lIns="0" tIns="0" rIns="0" bIns="0" rtlCol="0" anchor="ctr"/>
+          <a:lstStyle/>
+          <a:p>
+            <a:pPr marL="0" indent="0" algn="l">
+              <a:buNone/>
+            </a:pPr>
+            <a:r>
+              <a:rPr lang="en-US" sz="3400" b="1" dirty="0">
+                <a:solidFill>
+                  <a:schemeClr val="tx2"/>
+                </a:solidFill>
+              </a:rPr>
+              <a:t>Metodologia</a:t>
+            </a:r>
+            <a:endParaRPr lang="en-US" sz="3400" dirty="0"/>
+          </a:p>
+        </p:txBody>
+      </p:sp>
+      <p:sp>
+        <p:nvSpPr>
+          <p:cNvPr id="4" name="Tarjeta paso 1"/>
+          <p:cNvSpPr/>
+          <p:nvPr/>
+        </p:nvSpPr>
+        <p:spPr>
+          <a:xfrm>
+            <a:off x="548640" y="1508760"/>
+            <a:ext cx="1828800" cy="2377440"/>
+          </a:xfrm>
+          <a:prstGeom prst="roundRect">
+            <a:avLst>
+              <a:gd name="adj" fmla="val 6000"/>
+            </a:avLst>
+          </a:prstGeom>
+          <a:solidFill>
+            <a:schemeClr val="bg2"/>
+          </a:solidFill>
+          <a:ln/>
+          <a:effectLst>
+            <a:outerShdw sx="100000" sy="100000" kx="0" ky="0" algn="bl" rotWithShape="0" blurRad="101600" dist="25400" dir="5400000">
+              <a:srgbClr val="000000">
+                <a:alpha val="12000"/>
+              </a:srgbClr>
+            </a:outerShdw>
+          </a:effectLst>
+        </p:spPr>
+      </p:sp>
+      <p:sp>
+        <p:nvSpPr>
+          <p:cNvPr id="5" name="Círculo paso 1"/>
+          <p:cNvSpPr/>
+          <p:nvPr/>
+        </p:nvSpPr>
+        <p:spPr>
+          <a:xfrm>
+            <a:off x="777240" y="1783080"/>
+            <a:ext cx="548640" cy="548640"/>
+          </a:xfrm>
+          <a:prstGeom prst="ellipse">
+            <a:avLst/>
+          </a:prstGeom>
+          <a:solidFill>
+            <a:schemeClr val="accent1"/>
+          </a:solidFill>
+          <a:ln/>
+        </p:spPr>
+      </p:sp>
+      <p:sp>
+        <p:nvSpPr>
+          <p:cNvPr id="6" name="Número paso 1"/>
+          <p:cNvSpPr txBox="1"/>
+          <p:nvPr/>
+        </p:nvSpPr>
+        <p:spPr>
+          <a:xfrm>
+            <a:off x="777240" y="1783080"/>
+            <a:ext cx="548640" cy="548640"/>
+          </a:xfrm>
+          <a:prstGeom prst="rect">
+            <a:avLst/>
+          </a:prstGeom>
+          <a:noFill/>
+          <a:ln/>
+        </p:spPr>
+        <p:txBody>
+          <a:bodyPr wrap="square" lIns="0" tIns="0" rIns="0" bIns="0" rtlCol="0" anchor="ctr"/>
+          <a:lstStyle/>
+          <a:p>
+            <a:pPr algn="ctr" indent="0" marL="0">
+              <a:buNone/>
+            </a:pPr>
+            <a:r>
+              <a:rPr lang="en-US" sz="2000" b="1" dirty="0">
+                <a:solidFill>
+                  <a:schemeClr val="bg1"/>
+                </a:solidFill>
+                <a:latin typeface="Cambria" pitchFamily="34" charset="0"/>
+                <a:ea typeface="Cambria" pitchFamily="34" charset="-122"/>
+                <a:cs typeface="Cambria" pitchFamily="34" charset="-120"/>
+              </a:rPr>
+              <a:t>1</a:t>
+            </a:r>
+            <a:endParaRPr lang="en-US" sz="2000" dirty="0"/>
+          </a:p>
+        </p:txBody>
+      </p:sp>
+      <p:sp>
+        <p:nvSpPr>
+          <p:cNvPr id="7" name="Título paso 1"/>
+          <p:cNvSpPr txBox="1"/>
+          <p:nvPr/>
+        </p:nvSpPr>
+        <p:spPr>
+          <a:xfrm>
+            <a:off x="777240" y="2560320"/>
+            <a:ext cx="1463040" cy="457200"/>
+          </a:xfrm>
+          <a:prstGeom prst="rect">
+            <a:avLst/>
+          </a:prstGeom>
+          <a:noFill/>
+          <a:ln/>
+        </p:spPr>
+        <p:txBody>
+          <a:bodyPr wrap="square" lIns="0" tIns="0" rIns="0" bIns="0" rtlCol="0" anchor="t"/>
+          <a:lstStyle/>
+          <a:p>
+            <a:pPr indent="0" marL="0">
+              <a:buNone/>
+            </a:pPr>
+            <a:r>
+              <a:rPr lang="en-US" sz="1800" b="1" dirty="0">
+                <a:solidFill>
+                  <a:schemeClr val="tx2"/>
+                </a:solidFill>
+              </a:rPr>
+              <a:t>Diseinua</a:t>
+            </a:r>
+            <a:endParaRPr lang="en-US" sz="1800" dirty="0"/>
+          </a:p>
+        </p:txBody>
+      </p:sp>
+      <p:sp>
+        <p:nvSpPr>
+          <p:cNvPr id="8" name="Descripción paso 1"/>
+          <p:cNvSpPr txBox="1"/>
+          <p:nvPr/>
+        </p:nvSpPr>
+        <p:spPr>
+          <a:xfrm>
+            <a:off x="777240" y="3108960"/>
+            <a:ext cx="1463040" cy="914400"/>
+          </a:xfrm>
+          <a:prstGeom prst="rect">
+            <a:avLst/>
+          </a:prstGeom>
+          <a:noFill/>
+          <a:ln/>
+        </p:spPr>
+        <p:txBody>
+          <a:bodyPr wrap="square" lIns="0" tIns="0" rIns="0" bIns="0" rtlCol="0" anchor="t"/>
+          <a:lstStyle/>
+          <a:p>
+            <a:pPr indent="0" marL="0">
+              <a:buNone/>
+            </a:pPr>
+            <a:r>
+              <a:rPr lang="en-US" sz="1400" dirty="0">
+                <a:solidFill>
+                  <a:srgbClr val="64748B"/>
+                </a:solidFill>
+              </a:rPr>
+              <a:t>Ikuspegia eta azterketa mota</a:t>
+            </a:r>
+            <a:endParaRPr lang="en-US" sz="1400" dirty="0"/>
+          </a:p>
+        </p:txBody>
+      </p:sp>
+      <p:sp>
+        <p:nvSpPr>
+          <p:cNvPr id="9" name="Tarjeta paso 2"/>
+          <p:cNvSpPr/>
+          <p:nvPr/>
+        </p:nvSpPr>
+        <p:spPr>
+          <a:xfrm>
+            <a:off x="2621280" y="1508760"/>
+            <a:ext cx="1828800" cy="2377440"/>
+          </a:xfrm>
+          <a:prstGeom prst="roundRect">
+            <a:avLst>
+              <a:gd name="adj" fmla="val 6000"/>
+            </a:avLst>
+          </a:prstGeom>
+          <a:solidFill>
+            <a:schemeClr val="bg2"/>
+          </a:solidFill>
+          <a:ln/>
+          <a:effectLst>
+            <a:outerShdw sx="100000" sy="100000" kx="0" ky="0" algn="bl" rotWithShape="0" blurRad="101600" dist="25400" dir="5400000">
+              <a:srgbClr val="000000">
+                <a:alpha val="12000"/>
+              </a:srgbClr>
+            </a:outerShdw>
+          </a:effectLst>
+        </p:spPr>
+      </p:sp>
+      <p:sp>
+        <p:nvSpPr>
+          <p:cNvPr id="10" name="Círculo paso 2"/>
+          <p:cNvSpPr/>
+          <p:nvPr/>
+        </p:nvSpPr>
+        <p:spPr>
+          <a:xfrm>
+            <a:off x="2849880" y="1783080"/>
+            <a:ext cx="548640" cy="548640"/>
+          </a:xfrm>
+          <a:prstGeom prst="ellipse">
+            <a:avLst/>
+          </a:prstGeom>
+          <a:solidFill>
+            <a:schemeClr val="accent1"/>
+          </a:solidFill>
+          <a:ln/>
+        </p:spPr>
+      </p:sp>
+      <p:sp>
+        <p:nvSpPr>
+          <p:cNvPr id="11" name="Número paso 2"/>
+          <p:cNvSpPr txBox="1"/>
+          <p:nvPr/>
+        </p:nvSpPr>
+        <p:spPr>
+          <a:xfrm>
+            <a:off x="2849880" y="1783080"/>
+            <a:ext cx="548640" cy="548640"/>
+          </a:xfrm>
+          <a:prstGeom prst="rect">
+            <a:avLst/>
+          </a:prstGeom>
+          <a:noFill/>
+          <a:ln/>
+        </p:spPr>
+        <p:txBody>
+          <a:bodyPr wrap="square" lIns="0" tIns="0" rIns="0" bIns="0" rtlCol="0" anchor="ctr"/>
+          <a:lstStyle/>
+          <a:p>
+            <a:pPr algn="ctr" indent="0" marL="0">
+              <a:buNone/>
+            </a:pPr>
+            <a:r>
+              <a:rPr lang="en-US" sz="2000" b="1" dirty="0">
+                <a:solidFill>
+                  <a:schemeClr val="bg1"/>
+                </a:solidFill>
+                <a:latin typeface="Cambria" pitchFamily="34" charset="0"/>
+                <a:ea typeface="Cambria" pitchFamily="34" charset="-122"/>
+                <a:cs typeface="Cambria" pitchFamily="34" charset="-120"/>
+              </a:rPr>
+              <a:t>2</a:t>
+            </a:r>
+            <a:endParaRPr lang="en-US" sz="2000" dirty="0"/>
+          </a:p>
+        </p:txBody>
+      </p:sp>
+      <p:sp>
+        <p:nvSpPr>
+          <p:cNvPr id="12" name="Título paso 2"/>
+          <p:cNvSpPr txBox="1"/>
+          <p:nvPr/>
+        </p:nvSpPr>
+        <p:spPr>
+          <a:xfrm>
+            <a:off x="2849880" y="2560320"/>
+            <a:ext cx="1463040" cy="457200"/>
+          </a:xfrm>
+          <a:prstGeom prst="rect">
+            <a:avLst/>
+          </a:prstGeom>
+          <a:noFill/>
+          <a:ln/>
+        </p:spPr>
+        <p:txBody>
+          <a:bodyPr wrap="square" lIns="0" tIns="0" rIns="0" bIns="0" rtlCol="0" anchor="t"/>
+          <a:lstStyle/>
+          <a:p>
+            <a:pPr indent="0" marL="0">
+              <a:buNone/>
+            </a:pPr>
+            <a:r>
+              <a:rPr lang="en-US" sz="1800" b="1" dirty="0">
+                <a:solidFill>
+                  <a:schemeClr val="tx2"/>
+                </a:solidFill>
+              </a:rPr>
+              <a:t>Parte-hartzaileak</a:t>
+            </a:r>
+            <a:endParaRPr lang="en-US" sz="1800" dirty="0"/>
+          </a:p>
+        </p:txBody>
+      </p:sp>
+      <p:sp>
+        <p:nvSpPr>
+          <p:cNvPr id="13" name="Descripción paso 2"/>
+          <p:cNvSpPr txBox="1"/>
+          <p:nvPr/>
+        </p:nvSpPr>
+        <p:spPr>
+          <a:xfrm>
+            <a:off x="2849880" y="3108960"/>
+            <a:ext cx="1463040" cy="914400"/>
+          </a:xfrm>
+          <a:prstGeom prst="rect">
+            <a:avLst/>
+          </a:prstGeom>
+          <a:noFill/>
+          <a:ln/>
+        </p:spPr>
+        <p:txBody>
+          <a:bodyPr wrap="square" lIns="0" tIns="0" rIns="0" bIns="0" rtlCol="0" anchor="t"/>
+          <a:lstStyle/>
+          <a:p>
+            <a:pPr indent="0" marL="0">
+              <a:buNone/>
+            </a:pPr>
+            <a:r>
+              <a:rPr lang="en-US" sz="1400" dirty="0">
+                <a:solidFill>
+                  <a:srgbClr val="64748B"/>
+                </a:solidFill>
+              </a:rPr>
+              <a:t>Lagina eta testuingurua</a:t>
+            </a:r>
+            <a:endParaRPr lang="en-US" sz="1400" dirty="0"/>
+          </a:p>
+        </p:txBody>
+      </p:sp>
+      <p:sp>
+        <p:nvSpPr>
+          <p:cNvPr id="14" name="Tarjeta paso 3"/>
+          <p:cNvSpPr/>
+          <p:nvPr/>
+        </p:nvSpPr>
+        <p:spPr>
+          <a:xfrm>
+            <a:off x="4693920" y="1508760"/>
+            <a:ext cx="1828800" cy="2377440"/>
+          </a:xfrm>
+          <a:prstGeom prst="roundRect">
+            <a:avLst>
+              <a:gd name="adj" fmla="val 6000"/>
+            </a:avLst>
+          </a:prstGeom>
+          <a:solidFill>
+            <a:schemeClr val="bg2"/>
+          </a:solidFill>
+          <a:ln/>
+          <a:effectLst>
+            <a:outerShdw sx="100000" sy="100000" kx="0" ky="0" algn="bl" rotWithShape="0" blurRad="101600" dist="25400" dir="5400000">
+              <a:srgbClr val="000000">
+                <a:alpha val="12000"/>
+              </a:srgbClr>
+            </a:outerShdw>
+          </a:effectLst>
+        </p:spPr>
+      </p:sp>
+      <p:sp>
+        <p:nvSpPr>
+          <p:cNvPr id="15" name="Círculo paso 3"/>
+          <p:cNvSpPr/>
+          <p:nvPr/>
+        </p:nvSpPr>
+        <p:spPr>
+          <a:xfrm>
+            <a:off x="4922520" y="1783080"/>
+            <a:ext cx="548640" cy="548640"/>
+          </a:xfrm>
+          <a:prstGeom prst="ellipse">
+            <a:avLst/>
+          </a:prstGeom>
+          <a:solidFill>
+            <a:schemeClr val="accent1"/>
+          </a:solidFill>
+          <a:ln/>
+        </p:spPr>
+      </p:sp>
+      <p:sp>
+        <p:nvSpPr>
+          <p:cNvPr id="16" name="Número paso 3"/>
+          <p:cNvSpPr txBox="1"/>
+          <p:nvPr/>
+        </p:nvSpPr>
+        <p:spPr>
+          <a:xfrm>
+            <a:off x="4922520" y="1783080"/>
+            <a:ext cx="548640" cy="548640"/>
+          </a:xfrm>
+          <a:prstGeom prst="rect">
+            <a:avLst/>
+          </a:prstGeom>
+          <a:noFill/>
+          <a:ln/>
+        </p:spPr>
+        <p:txBody>
+          <a:bodyPr wrap="square" lIns="0" tIns="0" rIns="0" bIns="0" rtlCol="0" anchor="ctr"/>
+          <a:lstStyle/>
+          <a:p>
+            <a:pPr algn="ctr" indent="0" marL="0">
+              <a:buNone/>
+            </a:pPr>
+            <a:r>
+              <a:rPr lang="en-US" sz="2000" b="1" dirty="0">
+                <a:solidFill>
+                  <a:schemeClr val="bg1"/>
+                </a:solidFill>
+                <a:latin typeface="Cambria" pitchFamily="34" charset="0"/>
+                <a:ea typeface="Cambria" pitchFamily="34" charset="-122"/>
+                <a:cs typeface="Cambria" pitchFamily="34" charset="-120"/>
+              </a:rPr>
+              <a:t>3</a:t>
+            </a:r>
+            <a:endParaRPr lang="en-US" sz="2000" dirty="0"/>
+          </a:p>
+        </p:txBody>
+      </p:sp>
+      <p:sp>
+        <p:nvSpPr>
+          <p:cNvPr id="17" name="Título paso 3"/>
+          <p:cNvSpPr txBox="1"/>
+          <p:nvPr/>
+        </p:nvSpPr>
+        <p:spPr>
+          <a:xfrm>
+            <a:off x="4922520" y="2560320"/>
+            <a:ext cx="1463040" cy="457200"/>
+          </a:xfrm>
+          <a:prstGeom prst="rect">
+            <a:avLst/>
+          </a:prstGeom>
+          <a:noFill/>
+          <a:ln/>
+        </p:spPr>
+        <p:txBody>
+          <a:bodyPr wrap="square" lIns="0" tIns="0" rIns="0" bIns="0" rtlCol="0" anchor="t"/>
+          <a:lstStyle/>
+          <a:p>
+            <a:pPr indent="0" marL="0">
+              <a:buNone/>
+            </a:pPr>
+            <a:r>
+              <a:rPr lang="en-US" sz="1800" b="1" dirty="0">
+                <a:solidFill>
+                  <a:schemeClr val="tx2"/>
+                </a:solidFill>
+              </a:rPr>
+              <a:t>Tresnak</a:t>
+            </a:r>
+            <a:endParaRPr lang="en-US" sz="1800" dirty="0"/>
+          </a:p>
+        </p:txBody>
+      </p:sp>
+      <p:sp>
+        <p:nvSpPr>
+          <p:cNvPr id="18" name="Descripción paso 3"/>
+          <p:cNvSpPr txBox="1"/>
+          <p:nvPr/>
+        </p:nvSpPr>
+        <p:spPr>
+          <a:xfrm>
+            <a:off x="4922520" y="3108960"/>
+            <a:ext cx="1463040" cy="914400"/>
+          </a:xfrm>
+          <a:prstGeom prst="rect">
+            <a:avLst/>
+          </a:prstGeom>
+          <a:noFill/>
+          <a:ln/>
+        </p:spPr>
+        <p:txBody>
+          <a:bodyPr wrap="square" lIns="0" tIns="0" rIns="0" bIns="0" rtlCol="0" anchor="t"/>
+          <a:lstStyle/>
+          <a:p>
+            <a:pPr indent="0" marL="0">
+              <a:buNone/>
+            </a:pPr>
+            <a:r>
+              <a:rPr lang="en-US" sz="1400" dirty="0">
+                <a:solidFill>
+                  <a:srgbClr val="64748B"/>
+                </a:solidFill>
+              </a:rPr>
+              <a:t>Datuak biltzeko teknikak</a:t>
+            </a:r>
+            <a:endParaRPr lang="en-US" sz="1400" dirty="0"/>
+          </a:p>
+        </p:txBody>
+      </p:sp>
+      <p:sp>
+        <p:nvSpPr>
+          <p:cNvPr id="19" name="Tarjeta paso 4"/>
+          <p:cNvSpPr/>
+          <p:nvPr/>
+        </p:nvSpPr>
+        <p:spPr>
+          <a:xfrm>
+            <a:off x="6766560" y="1508760"/>
+            <a:ext cx="1828800" cy="2377440"/>
+          </a:xfrm>
+          <a:prstGeom prst="roundRect">
+            <a:avLst>
+              <a:gd name="adj" fmla="val 6000"/>
+            </a:avLst>
+          </a:prstGeom>
+          <a:solidFill>
+            <a:schemeClr val="bg2"/>
+          </a:solidFill>
+          <a:ln/>
+          <a:effectLst>
+            <a:outerShdw sx="100000" sy="100000" kx="0" ky="0" algn="bl" rotWithShape="0" blurRad="101600" dist="25400" dir="5400000">
+              <a:srgbClr val="000000">
+                <a:alpha val="12000"/>
+              </a:srgbClr>
+            </a:outerShdw>
+          </a:effectLst>
+        </p:spPr>
+      </p:sp>
+      <p:sp>
+        <p:nvSpPr>
+          <p:cNvPr id="20" name="Círculo paso 4"/>
+          <p:cNvSpPr/>
+          <p:nvPr/>
+        </p:nvSpPr>
+        <p:spPr>
+          <a:xfrm>
+            <a:off x="6995160" y="1783080"/>
+            <a:ext cx="548640" cy="548640"/>
+          </a:xfrm>
+          <a:prstGeom prst="ellipse">
+            <a:avLst/>
+          </a:prstGeom>
+          <a:solidFill>
+            <a:schemeClr val="accent4"/>
+          </a:solidFill>
+          <a:ln/>
+        </p:spPr>
+      </p:sp>
+      <p:sp>
+        <p:nvSpPr>
+          <p:cNvPr id="21" name="Número paso 4"/>
+          <p:cNvSpPr txBox="1"/>
+          <p:nvPr/>
+        </p:nvSpPr>
+        <p:spPr>
+          <a:xfrm>
+            <a:off x="6995160" y="1783080"/>
+            <a:ext cx="548640" cy="548640"/>
+          </a:xfrm>
+          <a:prstGeom prst="rect">
+            <a:avLst/>
+          </a:prstGeom>
+          <a:noFill/>
+          <a:ln/>
+        </p:spPr>
+        <p:txBody>
+          <a:bodyPr wrap="square" lIns="0" tIns="0" rIns="0" bIns="0" rtlCol="0" anchor="ctr"/>
+          <a:lstStyle/>
+          <a:p>
+            <a:pPr algn="ctr" indent="0" marL="0">
+              <a:buNone/>
+            </a:pPr>
+            <a:r>
+              <a:rPr lang="en-US" sz="2000" b="1" dirty="0">
+                <a:solidFill>
+                  <a:schemeClr val="bg1"/>
+                </a:solidFill>
+                <a:latin typeface="Cambria" pitchFamily="34" charset="0"/>
+                <a:ea typeface="Cambria" pitchFamily="34" charset="-122"/>
+                <a:cs typeface="Cambria" pitchFamily="34" charset="-120"/>
+              </a:rPr>
+              <a:t>4</a:t>
+            </a:r>
+            <a:endParaRPr lang="en-US" sz="2000" dirty="0"/>
+          </a:p>
+        </p:txBody>
+      </p:sp>
+      <p:sp>
+        <p:nvSpPr>
+          <p:cNvPr id="22" name="Título paso 4"/>
+          <p:cNvSpPr txBox="1"/>
+          <p:nvPr/>
+        </p:nvSpPr>
+        <p:spPr>
+          <a:xfrm>
+            <a:off x="6995160" y="2560320"/>
+            <a:ext cx="1463040" cy="457200"/>
+          </a:xfrm>
+          <a:prstGeom prst="rect">
+            <a:avLst/>
+          </a:prstGeom>
+          <a:noFill/>
+          <a:ln/>
+        </p:spPr>
+        <p:txBody>
+          <a:bodyPr wrap="square" lIns="0" tIns="0" rIns="0" bIns="0" rtlCol="0" anchor="t"/>
+          <a:lstStyle/>
+          <a:p>
+            <a:pPr indent="0" marL="0">
+              <a:buNone/>
+            </a:pPr>
+            <a:r>
+              <a:rPr lang="en-US" sz="1800" b="1" dirty="0">
+                <a:solidFill>
+                  <a:schemeClr val="tx2"/>
+                </a:solidFill>
+              </a:rPr>
+              <a:t>Azterketa</a:t>
+            </a:r>
+            <a:endParaRPr lang="en-US" sz="1800" dirty="0"/>
+          </a:p>
+        </p:txBody>
+      </p:sp>
+      <p:sp>
+        <p:nvSpPr>
+          <p:cNvPr id="23" name="Descripción paso 4"/>
+          <p:cNvSpPr txBox="1"/>
+          <p:nvPr/>
+        </p:nvSpPr>
+        <p:spPr>
+          <a:xfrm>
+            <a:off x="6995160" y="3108960"/>
+            <a:ext cx="1463040" cy="914400"/>
+          </a:xfrm>
+          <a:prstGeom prst="rect">
+            <a:avLst/>
+          </a:prstGeom>
+          <a:noFill/>
+          <a:ln/>
+        </p:spPr>
+        <p:txBody>
+          <a:bodyPr wrap="square" lIns="0" tIns="0" rIns="0" bIns="0" rtlCol="0" anchor="t"/>
+          <a:lstStyle/>
+          <a:p>
+            <a:pPr indent="0" marL="0">
+              <a:buNone/>
+            </a:pPr>
+            <a:r>
+              <a:rPr lang="en-US" sz="1400" dirty="0">
+                <a:solidFill>
+                  <a:srgbClr val="64748B"/>
+                </a:solidFill>
+              </a:rPr>
+              <a:t>Azterketa-prozedura</a:t>
+            </a:r>
+            <a:endParaRPr lang="en-US" sz="1400" dirty="0"/>
+          </a:p>
+        </p:txBody>
+      </p:sp>
+      <p:sp>
+        <p:nvSpPr>
+          <p:cNvPr id="24" name="Slide Number Placeholder 0"/>
+          <p:cNvSpPr>
+            <a:spLocks noGrp="1"/>
+          </p:cNvSpPr>
+          <p:nvPr>
+            <p:ph type="sldNum" sz="quarter" idx="4294967295"/>
+          </p:nvPr>
+        </p:nvSpPr>
+        <p:spPr>
+          <a:xfrm>
+            <a:off x="8138160" y="4681728"/>
+            <a:ext cx="457200" cy="274320"/>
+          </a:xfrm>
+          <a:prstGeom prst="rect">
+            <a:avLst/>
+          </a:prstGeom>
+          <a:extLst>
+            <a:ext uri="{C572A759-6A51-4108-AA02-DFA0A04FC94B}">
+              <ma14:wrappingTextBoxFlag xmlns="" xmlns:ma14="http://schemas.microsoft.com/office/mac/drawingml/2011/main" val="0"/>
+            </a:ext>
+          </a:extLst>
+        </p:spPr>
+        <p:txBody>
+          <a:bodyPr/>
+          <a:lstStyle>
+            <a:lvl1pPr>
+              <a:defRPr sz="1000">
+                <a:solidFill>
+                  <a:srgbClr val="64748B"/>
+                </a:solidFill>
+              </a:defRPr>
+            </a:lvl1pPr>
+          </a:lstStyle>
+          <a:p>
+            <a:pPr algn="r"/>
+            <a:fld id="{F7021451-1387-4CA6-816F-3879F97B5CBC}" type="slidenum">
+              <a:rPr lang="en-US" b="0"/>
+              <a:t>2</a:t>
+            </a:fld>
+            <a:endParaRPr lang="en-US"/>
           </a:p>
         </p:txBody>
       </p:sp>

</xml_diff>